<commit_message>
Align release evidence and remove legacy execution code
</commit_message>
<xml_diff>
--- a/artifacts/opticycle-slides.pptx
+++ b/artifacts/opticycle-slides.pptx
@@ -2,20 +2,20 @@
 <file path=ppt/presentation.xml><?xml version="1.0" encoding="utf-8"?>
 <p:presentation xmlns:p="http://schemas.openxmlformats.org/presentationml/2006/main">
   <p:sldMasterIdLst>
-    <p:sldMasterId xmlns:r="http://schemas.openxmlformats.org/officeDocument/2006/relationships" id="2147483648" r:id="R8013b3fc2ff94c9a"/>
+    <p:sldMasterId xmlns:r="http://schemas.openxmlformats.org/officeDocument/2006/relationships" id="2147483648" r:id="Re9c944b261a24fc2"/>
   </p:sldMasterIdLst>
   <p:notesMasterIdLst>
-    <p:notesMasterId xmlns:r="http://schemas.openxmlformats.org/officeDocument/2006/relationships" r:id="R460274987b374e25"/>
+    <p:notesMasterId xmlns:r="http://schemas.openxmlformats.org/officeDocument/2006/relationships" r:id="Rf708028bbb064aa6"/>
   </p:notesMasterIdLst>
   <p:sldIdLst>
-    <p:sldId xmlns:r="http://schemas.openxmlformats.org/officeDocument/2006/relationships" id="256" r:id="R0fe1a86f132a460e"/>
-    <p:sldId xmlns:r="http://schemas.openxmlformats.org/officeDocument/2006/relationships" id="257" r:id="R3f0c30f05422454f"/>
-    <p:sldId xmlns:r="http://schemas.openxmlformats.org/officeDocument/2006/relationships" id="258" r:id="R45a9ff5152624fe2"/>
-    <p:sldId xmlns:r="http://schemas.openxmlformats.org/officeDocument/2006/relationships" id="259" r:id="Rb7755b91f3ab4781"/>
-    <p:sldId xmlns:r="http://schemas.openxmlformats.org/officeDocument/2006/relationships" id="260" r:id="R71e625dbb515452a"/>
-    <p:sldId xmlns:r="http://schemas.openxmlformats.org/officeDocument/2006/relationships" id="261" r:id="R90e99e3c64e14f06"/>
-    <p:sldId xmlns:r="http://schemas.openxmlformats.org/officeDocument/2006/relationships" id="262" r:id="Rb2510bc9d4024631"/>
-    <p:sldId xmlns:r="http://schemas.openxmlformats.org/officeDocument/2006/relationships" id="263" r:id="Rfab92876a59b45d3"/>
+    <p:sldId xmlns:r="http://schemas.openxmlformats.org/officeDocument/2006/relationships" id="256" r:id="R22de5b99f84c4c40"/>
+    <p:sldId xmlns:r="http://schemas.openxmlformats.org/officeDocument/2006/relationships" id="257" r:id="R615283f8c2674050"/>
+    <p:sldId xmlns:r="http://schemas.openxmlformats.org/officeDocument/2006/relationships" id="258" r:id="R950528db81d84e64"/>
+    <p:sldId xmlns:r="http://schemas.openxmlformats.org/officeDocument/2006/relationships" id="259" r:id="R380caebde36946a5"/>
+    <p:sldId xmlns:r="http://schemas.openxmlformats.org/officeDocument/2006/relationships" id="260" r:id="Raeb17f37cf484968"/>
+    <p:sldId xmlns:r="http://schemas.openxmlformats.org/officeDocument/2006/relationships" id="261" r:id="R565ca9910feb449e"/>
+    <p:sldId xmlns:r="http://schemas.openxmlformats.org/officeDocument/2006/relationships" id="262" r:id="R9468777ff0844cc8"/>
+    <p:sldId xmlns:r="http://schemas.openxmlformats.org/officeDocument/2006/relationships" id="263" r:id="R21f4d82f77614495"/>
   </p:sldIdLst>
   <p:sldSz cx="12192000" cy="6858000"/>
   <p:notesSz cx="6858000" cy="9144000"/>
@@ -799,7 +799,7 @@
           <a:lstStyle xmlns:a="http://schemas.openxmlformats.org/drawingml/2006/main"/>
           <a:p xmlns:a="http://schemas.openxmlformats.org/drawingml/2006/main">
             <a:r>
-              <a:t>Live paper order ID and signed credit fill. Source: artifacts/evidence/broker_lookup.json and artifacts/evidence/sanitized_fills/oc-63db2a85298b4ecabefab59076a6397e.json.</a:t>
+              <a:t>Live paper order ID and signed credit fill. This receipt predates the current 3-10 DTE / $5 selector and proves execution plus broker reconciliation. Source: artifacts/evidence/broker_lookup.json and artifacts/evidence/sanitized_fills/oc-63db2a85298b4ecabefab59076a6397e.json.</a:t>
             </a:r>
           </a:p>
         </p:txBody>
@@ -1007,7 +1007,7 @@
   </p:cSld>
   <p:clrMap bg1="lt1" tx1="dk1" bg2="lt2" tx2="dk2" accent1="accent1" accent2="accent2" accent3="accent3" accent4="accent4" accent5="accent5" accent6="accent6" hlink="hlink" folHlink="folHlink"/>
   <p:sldLayoutIdLst>
-    <p:sldLayoutId xmlns:r="http://schemas.openxmlformats.org/officeDocument/2006/relationships" id="2147483649" r:id="R5a177fd99b164731"/>
+    <p:sldLayoutId xmlns:r="http://schemas.openxmlformats.org/officeDocument/2006/relationships" id="2147483649" r:id="Rb9843c28038c4f99"/>
   </p:sldLayoutIdLst>
   <p:txStyles>
     <p:titleStyle>
@@ -4658,14 +4658,14 @@
       </p:sp>
       <p:pic>
         <p:nvPicPr>
-          <p:cNvPr id="22" name=""/>
+          <p:cNvPr id="23" name=""/>
           <p:cNvPicPr>
             <a:picLocks xmlns:a="http://schemas.openxmlformats.org/drawingml/2006/main" noChangeAspect="1"/>
           </p:cNvPicPr>
           <p:nvPr/>
         </p:nvPicPr>
         <p:blipFill>
-          <a:blip xmlns:r="http://schemas.openxmlformats.org/officeDocument/2006/relationships" xmlns:a="http://schemas.openxmlformats.org/drawingml/2006/main" r:embed="R4964d84d2ecd48e8"/>
+          <a:blip xmlns:r="http://schemas.openxmlformats.org/officeDocument/2006/relationships" xmlns:a="http://schemas.openxmlformats.org/drawingml/2006/main" r:embed="R44649a4817cb4a5c"/>
           <a:stretch xmlns:a="http://schemas.openxmlformats.org/drawingml/2006/main"/>
         </p:blipFill>
         <p:spPr>
@@ -4713,6 +4713,7 @@
           <a:lstStyle xmlns:a="http://schemas.openxmlformats.org/drawingml/2006/main"/>
           <a:p xmlns:a="http://schemas.openxmlformats.org/drawingml/2006/main">
             <a:pPr algn="l">
+              <a:buNone/>
               <a:defRPr sz="1050" b="1">
                 <a:solidFill>
                   <a:srgbClr val="8FA3A0"/>
@@ -4731,7 +4732,7 @@
                 <a:ea typeface="Arial"/>
                 <a:cs typeface="Arial"/>
               </a:rPr>
-              <a:t>SANITIZED RECEIPT • GITHUB</a:t>
+              <a:t>EXECUTION PROOF - BEFORE 3-10 DTE / $5 POLICY</a:t>
             </a:r>
           </a:p>
         </p:txBody>

</xml_diff>